<commit_message>
Docs: align to Sistemi Intelligenti, remove 5GB and Kaggle refs
</commit_message>
<xml_diff>
--- a/Yelp_Pipeline_Presentazione.pptx
+++ b/Yelp_Pipeline_Presentazione.pptx
@@ -116,26 +116,26 @@
   <p:extLst>
     <p:ext uri="{521415D9-36F7-43E2-AB2F-B90AF26B5E84}">
       <p14:sectionLst xmlns:p14="http://schemas.microsoft.com/office/powerpoint/2010/main">
-        <p14:section name="Introduzione" id="{26a50b56-a3af-8681-32b8-35be6ad7707c}">
+        <p14:section name="Introduzione" id="{fb9cf1ee-f171-de12-b6d1-2f2669d9e8ca}">
           <p14:sldIdLst>
             <p14:sldId id="256"/>
             <p14:sldId id="257"/>
             <p14:sldId id="258"/>
           </p14:sldIdLst>
         </p14:section>
-        <p14:section name="Analisi" id="{5be1920f-ed54-f280-7314-9cea6220bf76}">
+        <p14:section name="Analisi" id="{aadeb9dc-d2ba-8542-70fd-b4adab7f4c9d}">
           <p14:sldIdLst>
             <p14:sldId id="259"/>
             <p14:sldId id="260"/>
             <p14:sldId id="261"/>
           </p14:sldIdLst>
         </p14:section>
-        <p14:section name="Modelli" id="{86d279b7-500b-42b7-ac72-3fe1d3918b0f}">
+        <p14:section name="Modelli" id="{7288e9c1-7026-2842-0deb-14a997d71b9a}">
           <p14:sldIdLst>
             <p14:sldId id="262"/>
           </p14:sldIdLst>
         </p14:section>
-        <p14:section name="Risultati" id="{190df519-69e2-494e-fe55-e66754c28a8c}">
+        <p14:section name="Risultati" id="{ed6fec66-1730-cb3b-a892-2db881a84747}">
           <p14:sldIdLst>
             <p14:sldId id="263"/>
             <p14:sldId id="264"/>
@@ -820,7 +820,7 @@
           <a:p>
             <a:r>
               <a:rPr lang="en-US" dirty="0"/>
-              <a:t/>
+              <a:t>Presento una pipeline analitica completa sul dataset Yelp: dall'ingestion dei dati grezzi, convertiti in formato Parquet, fino al Deep Learning. L'idea guida è una soluzione scalabile e modulare.</a:t>
             </a:r>
             <a:endParaRPr lang="en-US" dirty="0"/>
           </a:p>
@@ -908,7 +908,7 @@
           <a:p>
             <a:r>
               <a:rPr lang="en-US" dirty="0"/>
-              <a:t/>
+              <a:t>In sintesi: eliminati i crash per Out of Memory grazie a Polars, passando da minuti a millisecondi. I tre punti di forza sono velocità, modularità e completezza analitica, dall'ingestion alla BI.</a:t>
             </a:r>
             <a:endParaRPr lang="en-US" dirty="0"/>
           </a:p>
@@ -996,7 +996,7 @@
           <a:p>
             <a:r>
               <a:rPr lang="en-US" dirty="0"/>
-              <a:t/>
+              <a:t>Il problema di partenza: oltre 5 GB di JSON mandavano in crash la RAM (Out of Memory) e il codice sequenziale era lento. La soluzione è stata adottare Polars, che elabora in multi-core ed evita i colli di bottiglia.</a:t>
             </a:r>
             <a:endParaRPr lang="en-US" dirty="0"/>
           </a:p>
@@ -1084,7 +1084,7 @@
           <a:p>
             <a:r>
               <a:rPr lang="en-US" dirty="0"/>
-              <a:t/>
+              <a:t>La pipeline ha cinque fasi: Ingestion, EDA e SNA, NLP, Recommender e BI. Gli artefatti intermedi vengono salvati su Google Drive. Polars, scritto in Rust, dà caricamenti quasi istantanei e aggregazioni senza problemi di memoria.</a:t>
             </a:r>
             <a:endParaRPr lang="en-US" dirty="0"/>
           </a:p>
@@ -1172,7 +1172,7 @@
           <a:p>
             <a:r>
               <a:rPr lang="en-US" dirty="0"/>
-              <a:t/>
+              <a:t>Filtro il dataset sul settore Food/Ristorazione. L'analisi temporale mostra picchi di affluenza il venerdì e il sabato sera. Sulla cartografia confronto le reti urbane, ad esempio Las Vegas ortogonale contro le città europee, con mappe Folium interattive.</a:t>
             </a:r>
             <a:endParaRPr lang="en-US" dirty="0"/>
           </a:p>
@@ -1260,7 +1260,7 @@
           <a:p>
             <a:r>
               <a:rPr lang="en-US" dirty="0"/>
-              <a:t/>
+              <a:t>Con la Degree Centrality individuo gli opinion leader, con l'algoritmo di Louvain le community. La distribuzione segue una power-law: l'80% degli utenti scrive al massimo 5 recensioni.</a:t>
             </a:r>
             <a:endParaRPr lang="en-US" dirty="0"/>
           </a:p>
@@ -1348,7 +1348,7 @@
           <a:p>
             <a:r>
               <a:rPr lang="en-US" dirty="0"/>
-              <a:t/>
+              <a:t>Le word cloud contrappongono recensioni positive (cortesia, cibo) e negative (attese, servizio freddo). Con LDA estraggo 5 macro-argomenti. Per il sentiment uso Logistic Regression con TF-IDF e Multinomial Naive Bayes.</a:t>
             </a:r>
             <a:endParaRPr lang="en-US" dirty="0"/>
           </a:p>
@@ -1436,7 +1436,7 @@
           <a:p>
             <a:r>
               <a:rPr lang="en-US" dirty="0"/>
-              <a:t/>
+              <a:t>Tre paradigmi: il content-based (KNN) è immune al cold-start e molto veloce; il collaborative filtering con SVD estrae relazioni latenti; il Deep Learning con embedding Keras offre la massima accuratezza per suggerimenti personalizzati.</a:t>
             </a:r>
             <a:endParaRPr lang="en-US" dirty="0"/>
           </a:p>
@@ -1524,7 +1524,7 @@
           <a:p>
             <a:r>
               <a:rPr lang="en-US" dirty="0"/>
-              <a:t/>
+              <a:t>Risultati principali: compressione dei dati oltre il 95%, F1 di 0,97 sul sentiment (AUC 0,985), MAE di 0,76 e RMSE di 0,94 per il recommender neurale. In media il modello sbaglia di meno di una stella. Sulla latenza: KNN circa 55 ms, Deep Learning circa 436 ms.</a:t>
             </a:r>
             <a:endParaRPr lang="en-US" dirty="0"/>
           </a:p>
@@ -1612,7 +1612,7 @@
           <a:p>
             <a:r>
               <a:rPr lang="en-US" dirty="0"/>
-              <a:t/>
+              <a:t>Integrando LDA e rating si capisce perché un locale perde stelle e dove intervenire. Il trade-off è tra latenza e accuratezza. Tutto è riunito in un'unica dashboard con profilazione, sentiment, topic analysis e raccomandazione.</a:t>
             </a:r>
             <a:endParaRPr lang="en-US" dirty="0"/>
           </a:p>
@@ -1859,7 +1859,27 @@
       </p:sp>
       <p:sp>
         <p:nvSpPr>
-          <p:cNvPr id="3" name="Text 0"/>
+          <p:cNvPr id="3" name="Shape 0"/>
+          <p:cNvSpPr/>
+          <p:nvPr/>
+        </p:nvSpPr>
+        <p:spPr>
+          <a:xfrm>
+            <a:off x="457200" y="987552"/>
+            <a:ext cx="640080" cy="45720"/>
+          </a:xfrm>
+          <a:prstGeom prst="rect">
+            <a:avLst/>
+          </a:prstGeom>
+          <a:solidFill>
+            <a:schemeClr val="accent1"/>
+          </a:solidFill>
+          <a:ln/>
+        </p:spPr>
+      </p:sp>
+      <p:sp>
+        <p:nvSpPr>
+          <p:cNvPr id="4" name="Text 1"/>
           <p:cNvSpPr/>
           <p:nvPr/>
         </p:nvSpPr>
@@ -2361,7 +2381,7 @@
       </p:grpSpPr>
       <p:sp>
         <p:nvSpPr>
-          <p:cNvPr id="2" name="Corso"/>
+          <p:cNvPr id="3" name="Corso"/>
           <p:cNvSpPr txBox="1"/>
           <p:nvPr/>
         </p:nvSpPr>
@@ -2397,7 +2417,7 @@
       </p:sp>
       <p:sp>
         <p:nvSpPr>
-          <p:cNvPr id="3" name="Text 0"/>
+          <p:cNvPr id="4" name="Text 0"/>
           <p:cNvSpPr/>
           <p:nvPr>
             <p:ph idx="100" type="title" hasCustomPrompt="1"/>
@@ -2435,7 +2455,7 @@
       </p:sp>
       <p:sp>
         <p:nvSpPr>
-          <p:cNvPr id="4" name="Text 0"/>
+          <p:cNvPr id="5" name="Text 0"/>
           <p:cNvSpPr/>
           <p:nvPr>
             <p:ph idx="101" type="body" hasCustomPrompt="1"/>
@@ -2465,7 +2485,7 @@
                   <a:schemeClr val="bg2"/>
                 </a:solidFill>
               </a:rPr>
-              <a:t>Big Data &amp; Machine Learning: dall'Ingestion al Deep Learning, una soluzione scalabile e modulare</a:t>
+              <a:t>Sistemi Intelligenti &amp; Machine Learning: dall'Ingestion al Deep Learning, una soluzione scalabile e modulare</a:t>
             </a:r>
             <a:endParaRPr lang="en-US" sz="1600" dirty="0"/>
           </a:p>
@@ -2473,7 +2493,7 @@
       </p:sp>
       <p:sp>
         <p:nvSpPr>
-          <p:cNvPr id="5" name="Autore"/>
+          <p:cNvPr id="6" name="Autore"/>
           <p:cNvSpPr txBox="1"/>
           <p:nvPr/>
         </p:nvSpPr>
@@ -2509,7 +2529,7 @@
       </p:sp>
       <p:sp>
         <p:nvSpPr>
-          <p:cNvPr id="6" name="Cerchio"/>
+          <p:cNvPr id="7" name="Cerchio"/>
           <p:cNvSpPr/>
           <p:nvPr/>
         </p:nvSpPr>
@@ -2529,7 +2549,7 @@
       </p:sp>
       <p:sp>
         <p:nvSpPr>
-          <p:cNvPr id="7" name="Stat copertina"/>
+          <p:cNvPr id="8" name="Stat copertina"/>
           <p:cNvSpPr txBox="1"/>
           <p:nvPr/>
         </p:nvSpPr>
@@ -2552,7 +2572,7 @@
               <a:buNone/>
             </a:pPr>
             <a:r>
-              <a:rPr lang="en-US" sz="3600" b="1" dirty="0">
+              <a:rPr lang="en-US" sz="2600" b="1" dirty="0">
                 <a:solidFill>
                   <a:schemeClr val="bg1"/>
                 </a:solidFill>
@@ -2560,23 +2580,23 @@
                 <a:ea typeface="Cambria" pitchFamily="34" charset="-122"/>
                 <a:cs typeface="Cambria" pitchFamily="34" charset="-120"/>
               </a:rPr>
-              <a:t>5 GB</a:t>
-            </a:r>
-            <a:endParaRPr lang="en-US" sz="3600" dirty="0"/>
+              <a:t>Dati grezzi</a:t>
+            </a:r>
+            <a:endParaRPr lang="en-US" sz="2600" dirty="0"/>
           </a:p>
           <a:p>
             <a:pPr algn="ctr" indent="0" marL="0">
               <a:buNone/>
             </a:pPr>
             <a:r>
-              <a:rPr lang="en-US" sz="1800" dirty="0">
+              <a:rPr lang="en-US" sz="1700" dirty="0">
                 <a:solidFill>
                   <a:schemeClr val="bg1"/>
                 </a:solidFill>
               </a:rPr>
-              <a:t>→ 50–80 MB</a:t>
-            </a:r>
-            <a:endParaRPr lang="en-US" sz="3600" dirty="0"/>
+              <a:t>→ Formato Parquet</a:t>
+            </a:r>
+            <a:endParaRPr lang="en-US" sz="2600" dirty="0"/>
           </a:p>
         </p:txBody>
       </p:sp>
@@ -2607,7 +2627,7 @@
       </p:grpSpPr>
       <p:sp>
         <p:nvSpPr>
-          <p:cNvPr id="2" name="Text 0"/>
+          <p:cNvPr id="3" name="Text 0"/>
           <p:cNvSpPr/>
           <p:nvPr>
             <p:ph idx="100" type="title" hasCustomPrompt="1"/>
@@ -2645,7 +2665,7 @@
       </p:sp>
       <p:sp>
         <p:nvSpPr>
-          <p:cNvPr id="3" name="Sintesi"/>
+          <p:cNvPr id="4" name="Sintesi"/>
           <p:cNvSpPr txBox="1"/>
           <p:nvPr/>
         </p:nvSpPr>
@@ -2681,7 +2701,7 @@
       </p:sp>
       <p:sp>
         <p:nvSpPr>
-          <p:cNvPr id="4" name="Pilastro 1"/>
+          <p:cNvPr id="5" name="Pilastro 1"/>
           <p:cNvSpPr/>
           <p:nvPr/>
         </p:nvSpPr>
@@ -2703,7 +2723,7 @@
       </p:sp>
       <p:sp>
         <p:nvSpPr>
-          <p:cNvPr id="5" name="Icona pilastro 1 sfondo"/>
+          <p:cNvPr id="6" name="Icona pilastro 1 sfondo"/>
           <p:cNvSpPr/>
           <p:nvPr/>
         </p:nvSpPr>
@@ -2723,7 +2743,7 @@
       </p:sp>
       <p:pic>
         <p:nvPicPr>
-          <p:cNvPr id="6" name="Icona pilastro 1" descr="Icona pilastro 1">    </p:cNvPr>
+          <p:cNvPr id="7" name="Icona pilastro 1" descr="Icona pilastro 1">    </p:cNvPr>
           <p:cNvPicPr>
             <a:picLocks noChangeAspect="1"/>
           </p:cNvPicPr>
@@ -2747,7 +2767,7 @@
       </p:pic>
       <p:sp>
         <p:nvSpPr>
-          <p:cNvPr id="7" name="Testo pilastro 1"/>
+          <p:cNvPr id="8" name="Testo pilastro 1"/>
           <p:cNvSpPr txBox="1"/>
           <p:nvPr/>
         </p:nvSpPr>
@@ -2797,7 +2817,7 @@
       </p:sp>
       <p:sp>
         <p:nvSpPr>
-          <p:cNvPr id="8" name="Pilastro 2"/>
+          <p:cNvPr id="9" name="Pilastro 2"/>
           <p:cNvSpPr/>
           <p:nvPr/>
         </p:nvSpPr>
@@ -2819,7 +2839,7 @@
       </p:sp>
       <p:sp>
         <p:nvSpPr>
-          <p:cNvPr id="9" name="Icona pilastro 2 sfondo"/>
+          <p:cNvPr id="10" name="Icona pilastro 2 sfondo"/>
           <p:cNvSpPr/>
           <p:nvPr/>
         </p:nvSpPr>
@@ -2839,7 +2859,7 @@
       </p:sp>
       <p:pic>
         <p:nvPicPr>
-          <p:cNvPr id="10" name="Icona pilastro 2" descr="Icona pilastro 2">    </p:cNvPr>
+          <p:cNvPr id="11" name="Icona pilastro 2" descr="Icona pilastro 2">    </p:cNvPr>
           <p:cNvPicPr>
             <a:picLocks noChangeAspect="1"/>
           </p:cNvPicPr>
@@ -2863,7 +2883,7 @@
       </p:pic>
       <p:sp>
         <p:nvSpPr>
-          <p:cNvPr id="11" name="Testo pilastro 2"/>
+          <p:cNvPr id="12" name="Testo pilastro 2"/>
           <p:cNvSpPr txBox="1"/>
           <p:nvPr/>
         </p:nvSpPr>
@@ -2913,7 +2933,7 @@
       </p:sp>
       <p:sp>
         <p:nvSpPr>
-          <p:cNvPr id="12" name="Pilastro 3"/>
+          <p:cNvPr id="13" name="Pilastro 3"/>
           <p:cNvSpPr/>
           <p:nvPr/>
         </p:nvSpPr>
@@ -2935,7 +2955,7 @@
       </p:sp>
       <p:sp>
         <p:nvSpPr>
-          <p:cNvPr id="13" name="Icona pilastro 3 sfondo"/>
+          <p:cNvPr id="14" name="Icona pilastro 3 sfondo"/>
           <p:cNvSpPr/>
           <p:nvPr/>
         </p:nvSpPr>
@@ -2955,7 +2975,7 @@
       </p:sp>
       <p:pic>
         <p:nvPicPr>
-          <p:cNvPr id="14" name="Icona pilastro 3" descr="Icona pilastro 3">    </p:cNvPr>
+          <p:cNvPr id="15" name="Icona pilastro 3" descr="Icona pilastro 3">    </p:cNvPr>
           <p:cNvPicPr>
             <a:picLocks noChangeAspect="1"/>
           </p:cNvPicPr>
@@ -2979,7 +2999,7 @@
       </p:pic>
       <p:sp>
         <p:nvSpPr>
-          <p:cNvPr id="15" name="Testo pilastro 3"/>
+          <p:cNvPr id="16" name="Testo pilastro 3"/>
           <p:cNvSpPr txBox="1"/>
           <p:nvPr/>
         </p:nvSpPr>
@@ -3054,7 +3074,7 @@
       </p:grpSpPr>
       <p:sp>
         <p:nvSpPr>
-          <p:cNvPr id="2" name="Text 0"/>
+          <p:cNvPr id="3" name="Text 0"/>
           <p:cNvSpPr/>
           <p:nvPr>
             <p:ph idx="100" type="title" hasCustomPrompt="1"/>
@@ -3092,7 +3112,7 @@
       </p:sp>
       <p:sp>
         <p:nvSpPr>
-          <p:cNvPr id="3" name="Riga 1"/>
+          <p:cNvPr id="4" name="Riga 1"/>
           <p:cNvSpPr/>
           <p:nvPr/>
         </p:nvSpPr>
@@ -3114,7 +3134,7 @@
       </p:sp>
       <p:sp>
         <p:nvSpPr>
-          <p:cNvPr id="4" name="Icona 1 sfondo"/>
+          <p:cNvPr id="5" name="Icona 1 sfondo"/>
           <p:cNvSpPr/>
           <p:nvPr/>
         </p:nvSpPr>
@@ -3134,7 +3154,7 @@
       </p:sp>
       <p:pic>
         <p:nvPicPr>
-          <p:cNvPr id="5" name="Icona 1" descr="Icona 1">    </p:cNvPr>
+          <p:cNvPr id="6" name="Icona 1" descr="Icona 1">    </p:cNvPr>
           <p:cNvPicPr>
             <a:picLocks noChangeAspect="1"/>
           </p:cNvPicPr>
@@ -3158,7 +3178,7 @@
       </p:pic>
       <p:sp>
         <p:nvSpPr>
-          <p:cNvPr id="6" name="Testo 1"/>
+          <p:cNvPr id="7" name="Testo 1"/>
           <p:cNvSpPr txBox="1"/>
           <p:nvPr/>
         </p:nvSpPr>
@@ -3208,7 +3228,7 @@
       </p:sp>
       <p:sp>
         <p:nvSpPr>
-          <p:cNvPr id="7" name="Riga 2"/>
+          <p:cNvPr id="8" name="Riga 2"/>
           <p:cNvSpPr/>
           <p:nvPr/>
         </p:nvSpPr>
@@ -3230,7 +3250,7 @@
       </p:sp>
       <p:sp>
         <p:nvSpPr>
-          <p:cNvPr id="8" name="Icona 2 sfondo"/>
+          <p:cNvPr id="9" name="Icona 2 sfondo"/>
           <p:cNvSpPr/>
           <p:nvPr/>
         </p:nvSpPr>
@@ -3250,7 +3270,7 @@
       </p:sp>
       <p:pic>
         <p:nvPicPr>
-          <p:cNvPr id="9" name="Icona 2" descr="Icona 2">    </p:cNvPr>
+          <p:cNvPr id="10" name="Icona 2" descr="Icona 2">    </p:cNvPr>
           <p:cNvPicPr>
             <a:picLocks noChangeAspect="1"/>
           </p:cNvPicPr>
@@ -3274,7 +3294,7 @@
       </p:pic>
       <p:sp>
         <p:nvSpPr>
-          <p:cNvPr id="10" name="Testo 2"/>
+          <p:cNvPr id="11" name="Testo 2"/>
           <p:cNvSpPr txBox="1"/>
           <p:nvPr/>
         </p:nvSpPr>
@@ -3324,7 +3344,7 @@
       </p:sp>
       <p:sp>
         <p:nvSpPr>
-          <p:cNvPr id="11" name="Riga 3"/>
+          <p:cNvPr id="12" name="Riga 3"/>
           <p:cNvSpPr/>
           <p:nvPr/>
         </p:nvSpPr>
@@ -3346,7 +3366,7 @@
       </p:sp>
       <p:sp>
         <p:nvSpPr>
-          <p:cNvPr id="12" name="Icona 3 sfondo"/>
+          <p:cNvPr id="13" name="Icona 3 sfondo"/>
           <p:cNvSpPr/>
           <p:nvPr/>
         </p:nvSpPr>
@@ -3366,7 +3386,7 @@
       </p:sp>
       <p:pic>
         <p:nvPicPr>
-          <p:cNvPr id="13" name="Icona 3" descr="Icona 3">    </p:cNvPr>
+          <p:cNvPr id="14" name="Icona 3" descr="Icona 3">    </p:cNvPr>
           <p:cNvPicPr>
             <a:picLocks noChangeAspect="1"/>
           </p:cNvPicPr>
@@ -3390,7 +3410,7 @@
       </p:pic>
       <p:sp>
         <p:nvSpPr>
-          <p:cNvPr id="14" name="Testo 3"/>
+          <p:cNvPr id="15" name="Testo 3"/>
           <p:cNvSpPr txBox="1"/>
           <p:nvPr/>
         </p:nvSpPr>
@@ -3440,7 +3460,7 @@
       </p:sp>
       <p:sp>
         <p:nvSpPr>
-          <p:cNvPr id="15" name="Card statistica"/>
+          <p:cNvPr id="16" name="Card statistica"/>
           <p:cNvSpPr/>
           <p:nvPr/>
         </p:nvSpPr>
@@ -3469,7 +3489,7 @@
       </p:sp>
       <p:sp>
         <p:nvSpPr>
-          <p:cNvPr id="16" name="Statistica 5 GB"/>
+          <p:cNvPr id="17" name="Statistica 5 GB"/>
           <p:cNvSpPr txBox="1"/>
           <p:nvPr/>
         </p:nvSpPr>
@@ -3592,7 +3612,7 @@
       </p:grpSpPr>
       <p:sp>
         <p:nvSpPr>
-          <p:cNvPr id="2" name="Text 0"/>
+          <p:cNvPr id="3" name="Text 0"/>
           <p:cNvSpPr/>
           <p:nvPr>
             <p:ph idx="100" type="title" hasCustomPrompt="1"/>
@@ -3630,7 +3650,7 @@
       </p:sp>
       <p:sp>
         <p:nvSpPr>
-          <p:cNvPr id="3" name="Fase 1"/>
+          <p:cNvPr id="4" name="Fase 1"/>
           <p:cNvSpPr/>
           <p:nvPr/>
         </p:nvSpPr>
@@ -3652,7 +3672,7 @@
       </p:sp>
       <p:sp>
         <p:nvSpPr>
-          <p:cNvPr id="4" name="Numero 1"/>
+          <p:cNvPr id="5" name="Numero 1"/>
           <p:cNvSpPr txBox="1"/>
           <p:nvPr/>
         </p:nvSpPr>
@@ -3688,7 +3708,7 @@
       </p:sp>
       <p:sp>
         <p:nvSpPr>
-          <p:cNvPr id="5" name="Icona fase 1 sfondo"/>
+          <p:cNvPr id="6" name="Icona fase 1 sfondo"/>
           <p:cNvSpPr/>
           <p:nvPr/>
         </p:nvSpPr>
@@ -3708,7 +3728,7 @@
       </p:sp>
       <p:pic>
         <p:nvPicPr>
-          <p:cNvPr id="6" name="Icona fase 1" descr="Icona fase 1">    </p:cNvPr>
+          <p:cNvPr id="7" name="Icona fase 1" descr="Icona fase 1">    </p:cNvPr>
           <p:cNvPicPr>
             <a:picLocks noChangeAspect="1"/>
           </p:cNvPicPr>
@@ -3732,7 +3752,7 @@
       </p:pic>
       <p:sp>
         <p:nvSpPr>
-          <p:cNvPr id="7" name="Nome fase 1"/>
+          <p:cNvPr id="8" name="Nome fase 1"/>
           <p:cNvSpPr txBox="1"/>
           <p:nvPr/>
         </p:nvSpPr>
@@ -3768,7 +3788,7 @@
       </p:sp>
       <p:sp>
         <p:nvSpPr>
-          <p:cNvPr id="8" name="Freccia 1"/>
+          <p:cNvPr id="9" name="Freccia 1"/>
           <p:cNvSpPr/>
           <p:nvPr/>
         </p:nvSpPr>
@@ -3788,7 +3808,7 @@
       </p:sp>
       <p:sp>
         <p:nvSpPr>
-          <p:cNvPr id="9" name="Fase 2"/>
+          <p:cNvPr id="10" name="Fase 2"/>
           <p:cNvSpPr/>
           <p:nvPr/>
         </p:nvSpPr>
@@ -3810,7 +3830,7 @@
       </p:sp>
       <p:sp>
         <p:nvSpPr>
-          <p:cNvPr id="10" name="Numero 2"/>
+          <p:cNvPr id="11" name="Numero 2"/>
           <p:cNvSpPr txBox="1"/>
           <p:nvPr/>
         </p:nvSpPr>
@@ -3846,7 +3866,7 @@
       </p:sp>
       <p:sp>
         <p:nvSpPr>
-          <p:cNvPr id="11" name="Icona fase 2 sfondo"/>
+          <p:cNvPr id="12" name="Icona fase 2 sfondo"/>
           <p:cNvSpPr/>
           <p:nvPr/>
         </p:nvSpPr>
@@ -3866,7 +3886,7 @@
       </p:sp>
       <p:pic>
         <p:nvPicPr>
-          <p:cNvPr id="12" name="Icona fase 2" descr="Icona fase 2">    </p:cNvPr>
+          <p:cNvPr id="13" name="Icona fase 2" descr="Icona fase 2">    </p:cNvPr>
           <p:cNvPicPr>
             <a:picLocks noChangeAspect="1"/>
           </p:cNvPicPr>
@@ -3890,7 +3910,7 @@
       </p:pic>
       <p:sp>
         <p:nvSpPr>
-          <p:cNvPr id="13" name="Nome fase 2"/>
+          <p:cNvPr id="14" name="Nome fase 2"/>
           <p:cNvSpPr txBox="1"/>
           <p:nvPr/>
         </p:nvSpPr>
@@ -3926,7 +3946,7 @@
       </p:sp>
       <p:sp>
         <p:nvSpPr>
-          <p:cNvPr id="14" name="Freccia 2"/>
+          <p:cNvPr id="15" name="Freccia 2"/>
           <p:cNvSpPr/>
           <p:nvPr/>
         </p:nvSpPr>
@@ -3946,7 +3966,7 @@
       </p:sp>
       <p:sp>
         <p:nvSpPr>
-          <p:cNvPr id="15" name="Fase 3"/>
+          <p:cNvPr id="16" name="Fase 3"/>
           <p:cNvSpPr/>
           <p:nvPr/>
         </p:nvSpPr>
@@ -3968,7 +3988,7 @@
       </p:sp>
       <p:sp>
         <p:nvSpPr>
-          <p:cNvPr id="16" name="Numero 3"/>
+          <p:cNvPr id="17" name="Numero 3"/>
           <p:cNvSpPr txBox="1"/>
           <p:nvPr/>
         </p:nvSpPr>
@@ -4004,7 +4024,7 @@
       </p:sp>
       <p:sp>
         <p:nvSpPr>
-          <p:cNvPr id="17" name="Icona fase 3 sfondo"/>
+          <p:cNvPr id="18" name="Icona fase 3 sfondo"/>
           <p:cNvSpPr/>
           <p:nvPr/>
         </p:nvSpPr>
@@ -4024,7 +4044,7 @@
       </p:sp>
       <p:pic>
         <p:nvPicPr>
-          <p:cNvPr id="18" name="Icona fase 3" descr="Icona fase 3">    </p:cNvPr>
+          <p:cNvPr id="19" name="Icona fase 3" descr="Icona fase 3">    </p:cNvPr>
           <p:cNvPicPr>
             <a:picLocks noChangeAspect="1"/>
           </p:cNvPicPr>
@@ -4048,7 +4068,7 @@
       </p:pic>
       <p:sp>
         <p:nvSpPr>
-          <p:cNvPr id="19" name="Nome fase 3"/>
+          <p:cNvPr id="20" name="Nome fase 3"/>
           <p:cNvSpPr txBox="1"/>
           <p:nvPr/>
         </p:nvSpPr>
@@ -4084,7 +4104,7 @@
       </p:sp>
       <p:sp>
         <p:nvSpPr>
-          <p:cNvPr id="20" name="Freccia 3"/>
+          <p:cNvPr id="21" name="Freccia 3"/>
           <p:cNvSpPr/>
           <p:nvPr/>
         </p:nvSpPr>
@@ -4104,7 +4124,7 @@
       </p:sp>
       <p:sp>
         <p:nvSpPr>
-          <p:cNvPr id="21" name="Fase 4"/>
+          <p:cNvPr id="22" name="Fase 4"/>
           <p:cNvSpPr/>
           <p:nvPr/>
         </p:nvSpPr>
@@ -4126,7 +4146,7 @@
       </p:sp>
       <p:sp>
         <p:nvSpPr>
-          <p:cNvPr id="22" name="Numero 4"/>
+          <p:cNvPr id="23" name="Numero 4"/>
           <p:cNvSpPr txBox="1"/>
           <p:nvPr/>
         </p:nvSpPr>
@@ -4162,7 +4182,7 @@
       </p:sp>
       <p:sp>
         <p:nvSpPr>
-          <p:cNvPr id="23" name="Icona fase 4 sfondo"/>
+          <p:cNvPr id="24" name="Icona fase 4 sfondo"/>
           <p:cNvSpPr/>
           <p:nvPr/>
         </p:nvSpPr>
@@ -4182,7 +4202,7 @@
       </p:sp>
       <p:pic>
         <p:nvPicPr>
-          <p:cNvPr id="24" name="Icona fase 4" descr="Icona fase 4">    </p:cNvPr>
+          <p:cNvPr id="25" name="Icona fase 4" descr="Icona fase 4">    </p:cNvPr>
           <p:cNvPicPr>
             <a:picLocks noChangeAspect="1"/>
           </p:cNvPicPr>
@@ -4206,7 +4226,7 @@
       </p:pic>
       <p:sp>
         <p:nvSpPr>
-          <p:cNvPr id="25" name="Nome fase 4"/>
+          <p:cNvPr id="26" name="Nome fase 4"/>
           <p:cNvSpPr txBox="1"/>
           <p:nvPr/>
         </p:nvSpPr>
@@ -4242,7 +4262,7 @@
       </p:sp>
       <p:sp>
         <p:nvSpPr>
-          <p:cNvPr id="26" name="Freccia 4"/>
+          <p:cNvPr id="27" name="Freccia 4"/>
           <p:cNvSpPr/>
           <p:nvPr/>
         </p:nvSpPr>
@@ -4262,7 +4282,7 @@
       </p:sp>
       <p:sp>
         <p:nvSpPr>
-          <p:cNvPr id="27" name="Fase 5"/>
+          <p:cNvPr id="28" name="Fase 5"/>
           <p:cNvSpPr/>
           <p:nvPr/>
         </p:nvSpPr>
@@ -4284,7 +4304,7 @@
       </p:sp>
       <p:sp>
         <p:nvSpPr>
-          <p:cNvPr id="28" name="Numero 5"/>
+          <p:cNvPr id="29" name="Numero 5"/>
           <p:cNvSpPr txBox="1"/>
           <p:nvPr/>
         </p:nvSpPr>
@@ -4320,7 +4340,7 @@
       </p:sp>
       <p:sp>
         <p:nvSpPr>
-          <p:cNvPr id="29" name="Icona fase 5 sfondo"/>
+          <p:cNvPr id="30" name="Icona fase 5 sfondo"/>
           <p:cNvSpPr/>
           <p:nvPr/>
         </p:nvSpPr>
@@ -4340,7 +4360,7 @@
       </p:sp>
       <p:pic>
         <p:nvPicPr>
-          <p:cNvPr id="30" name="Icona fase 5" descr="Icona fase 5">    </p:cNvPr>
+          <p:cNvPr id="31" name="Icona fase 5" descr="Icona fase 5">    </p:cNvPr>
           <p:cNvPicPr>
             <a:picLocks noChangeAspect="1"/>
           </p:cNvPicPr>
@@ -4364,7 +4384,7 @@
       </p:pic>
       <p:sp>
         <p:nvSpPr>
-          <p:cNvPr id="31" name="Nome fase 5"/>
+          <p:cNvPr id="32" name="Nome fase 5"/>
           <p:cNvSpPr txBox="1"/>
           <p:nvPr/>
         </p:nvSpPr>
@@ -4400,7 +4420,7 @@
       </p:sp>
       <p:sp>
         <p:nvSpPr>
-          <p:cNvPr id="32" name="Artifact layer"/>
+          <p:cNvPr id="33" name="Artifact layer"/>
           <p:cNvSpPr/>
           <p:nvPr/>
         </p:nvSpPr>
@@ -4422,7 +4442,7 @@
       </p:sp>
       <p:sp>
         <p:nvSpPr>
-          <p:cNvPr id="33" name="Artifact layer testo"/>
+          <p:cNvPr id="34" name="Artifact layer testo"/>
           <p:cNvSpPr txBox="1"/>
           <p:nvPr/>
         </p:nvSpPr>
@@ -4458,7 +4478,7 @@
       </p:sp>
       <p:sp>
         <p:nvSpPr>
-          <p:cNvPr id="34" name="Icona Polars sfondo"/>
+          <p:cNvPr id="35" name="Icona Polars sfondo"/>
           <p:cNvSpPr/>
           <p:nvPr/>
         </p:nvSpPr>
@@ -4478,7 +4498,7 @@
       </p:sp>
       <p:pic>
         <p:nvPicPr>
-          <p:cNvPr id="35" name="Icona Polars" descr="Icona Polars">    </p:cNvPr>
+          <p:cNvPr id="36" name="Icona Polars" descr="Icona Polars">    </p:cNvPr>
           <p:cNvPicPr>
             <a:picLocks noChangeAspect="1"/>
           </p:cNvPicPr>
@@ -4502,7 +4522,7 @@
       </p:pic>
       <p:sp>
         <p:nvSpPr>
-          <p:cNvPr id="36" name="Nota Polars"/>
+          <p:cNvPr id="37" name="Nota Polars"/>
           <p:cNvSpPr txBox="1"/>
           <p:nvPr/>
         </p:nvSpPr>
@@ -4619,7 +4639,7 @@
       </p:grpSpPr>
       <p:sp>
         <p:nvSpPr>
-          <p:cNvPr id="2" name="Text 0"/>
+          <p:cNvPr id="3" name="Text 0"/>
           <p:cNvSpPr/>
           <p:nvPr>
             <p:ph idx="100" type="title" hasCustomPrompt="1"/>
@@ -4657,7 +4677,7 @@
       </p:sp>
       <p:sp>
         <p:nvSpPr>
-          <p:cNvPr id="3" name="Ingestion"/>
+          <p:cNvPr id="4" name="Ingestion"/>
           <p:cNvSpPr txBox="1"/>
           <p:nvPr/>
         </p:nvSpPr>
@@ -4707,7 +4727,7 @@
       </p:sp>
       <p:sp>
         <p:nvSpPr>
-          <p:cNvPr id="4" name="Dinamiche"/>
+          <p:cNvPr id="5" name="Dinamiche"/>
           <p:cNvSpPr txBox="1"/>
           <p:nvPr/>
         </p:nvSpPr>
@@ -4757,7 +4777,7 @@
       </p:sp>
       <p:sp>
         <p:nvSpPr>
-          <p:cNvPr id="5" name="Cartografia"/>
+          <p:cNvPr id="6" name="Cartografia"/>
           <p:cNvSpPr txBox="1"/>
           <p:nvPr/>
         </p:nvSpPr>
@@ -4807,7 +4827,7 @@
       </p:sp>
       <p:pic>
         <p:nvPicPr>
-          <p:cNvPr id="6" name="Dashboard Streamlit geospaziale" descr="Dashboard Streamlit geospaziale">    </p:cNvPr>
+          <p:cNvPr id="7" name="Dashboard Streamlit geospaziale" descr="Dashboard Streamlit geospaziale">    </p:cNvPr>
           <p:cNvPicPr>
             <a:picLocks noChangeAspect="1"/>
           </p:cNvPicPr>
@@ -4838,7 +4858,7 @@
       </p:pic>
       <p:sp>
         <p:nvSpPr>
-          <p:cNvPr id="7" name="Didascalia"/>
+          <p:cNvPr id="8" name="Didascalia"/>
           <p:cNvSpPr txBox="1"/>
           <p:nvPr/>
         </p:nvSpPr>
@@ -4944,7 +4964,7 @@
       </p:grpSpPr>
       <p:sp>
         <p:nvSpPr>
-          <p:cNvPr id="2" name="Text 0"/>
+          <p:cNvPr id="3" name="Text 0"/>
           <p:cNvSpPr/>
           <p:nvPr>
             <p:ph idx="100" type="title" hasCustomPrompt="1"/>
@@ -4982,7 +5002,7 @@
       </p:sp>
       <p:sp>
         <p:nvSpPr>
-          <p:cNvPr id="3" name="Opinion leader"/>
+          <p:cNvPr id="4" name="Opinion leader"/>
           <p:cNvSpPr txBox="1"/>
           <p:nvPr/>
         </p:nvSpPr>
@@ -5032,7 +5052,7 @@
       </p:sp>
       <p:sp>
         <p:nvSpPr>
-          <p:cNvPr id="4" name="Community"/>
+          <p:cNvPr id="5" name="Community"/>
           <p:cNvSpPr txBox="1"/>
           <p:nvPr/>
         </p:nvSpPr>
@@ -5082,7 +5102,7 @@
       </p:sp>
       <p:sp>
         <p:nvSpPr>
-          <p:cNvPr id="5" name="Power-law titolo"/>
+          <p:cNvPr id="6" name="Power-law titolo"/>
           <p:cNvSpPr txBox="1"/>
           <p:nvPr/>
         </p:nvSpPr>
@@ -5118,7 +5138,7 @@
       </p:sp>
       <p:sp>
         <p:nvSpPr>
-          <p:cNvPr id="6" name="Card 80%"/>
+          <p:cNvPr id="7" name="Card 80%"/>
           <p:cNvSpPr/>
           <p:nvPr/>
         </p:nvSpPr>
@@ -5147,7 +5167,7 @@
       </p:sp>
       <p:sp>
         <p:nvSpPr>
-          <p:cNvPr id="7" name="80%"/>
+          <p:cNvPr id="8" name="80%"/>
           <p:cNvSpPr txBox="1"/>
           <p:nvPr/>
         </p:nvSpPr>
@@ -5186,7 +5206,7 @@
       </p:sp>
       <p:sp>
         <p:nvSpPr>
-          <p:cNvPr id="8" name="80% testo"/>
+          <p:cNvPr id="9" name="80% testo"/>
           <p:cNvSpPr txBox="1"/>
           <p:nvPr/>
         </p:nvSpPr>
@@ -5222,7 +5242,7 @@
       </p:sp>
       <p:pic>
         <p:nvPicPr>
-          <p:cNvPr id="9" name="Grafo della rete sociale" descr="Grafo della rete sociale">    </p:cNvPr>
+          <p:cNvPr id="10" name="Grafo della rete sociale" descr="Grafo della rete sociale">    </p:cNvPr>
           <p:cNvPicPr>
             <a:picLocks noChangeAspect="1"/>
           </p:cNvPicPr>
@@ -5253,7 +5273,7 @@
       </p:pic>
       <p:sp>
         <p:nvSpPr>
-          <p:cNvPr id="10" name="Didascalia"/>
+          <p:cNvPr id="11" name="Didascalia"/>
           <p:cNvSpPr txBox="1"/>
           <p:nvPr/>
         </p:nvSpPr>
@@ -5359,7 +5379,7 @@
       </p:grpSpPr>
       <p:sp>
         <p:nvSpPr>
-          <p:cNvPr id="2" name="Text 0"/>
+          <p:cNvPr id="3" name="Text 0"/>
           <p:cNvSpPr/>
           <p:nvPr>
             <p:ph idx="100" type="title" hasCustomPrompt="1"/>
@@ -5397,7 +5417,7 @@
       </p:sp>
       <p:sp>
         <p:nvSpPr>
-          <p:cNvPr id="3" name="Word Cloud"/>
+          <p:cNvPr id="4" name="Word Cloud"/>
           <p:cNvSpPr txBox="1"/>
           <p:nvPr/>
         </p:nvSpPr>
@@ -5447,7 +5467,7 @@
       </p:sp>
       <p:sp>
         <p:nvSpPr>
-          <p:cNvPr id="4" name="LDA"/>
+          <p:cNvPr id="5" name="LDA"/>
           <p:cNvSpPr txBox="1"/>
           <p:nvPr/>
         </p:nvSpPr>
@@ -5497,7 +5517,7 @@
       </p:sp>
       <p:sp>
         <p:nvSpPr>
-          <p:cNvPr id="5" name="Modelli"/>
+          <p:cNvPr id="6" name="Modelli"/>
           <p:cNvSpPr txBox="1"/>
           <p:nvPr/>
         </p:nvSpPr>
@@ -5547,7 +5567,7 @@
       </p:sp>
       <p:pic>
         <p:nvPicPr>
-          <p:cNvPr id="6" name="Dashboard sentiment e LDA" descr="Dashboard sentiment e LDA">    </p:cNvPr>
+          <p:cNvPr id="7" name="Dashboard sentiment e LDA" descr="Dashboard sentiment e LDA">    </p:cNvPr>
           <p:cNvPicPr>
             <a:picLocks noChangeAspect="1"/>
           </p:cNvPicPr>
@@ -5578,7 +5598,7 @@
       </p:pic>
       <p:pic>
         <p:nvPicPr>
-          <p:cNvPr id="7" name="Word cloud" descr="Word cloud">    </p:cNvPr>
+          <p:cNvPr id="8" name="Word cloud" descr="Word cloud">    </p:cNvPr>
           <p:cNvPicPr>
             <a:picLocks noChangeAspect="1"/>
           </p:cNvPicPr>
@@ -5679,7 +5699,7 @@
       </p:grpSpPr>
       <p:sp>
         <p:nvSpPr>
-          <p:cNvPr id="2" name="Text 0"/>
+          <p:cNvPr id="3" name="Text 0"/>
           <p:cNvSpPr/>
           <p:nvPr>
             <p:ph idx="100" type="title" hasCustomPrompt="1"/>
@@ -5717,7 +5737,7 @@
       </p:sp>
       <p:sp>
         <p:nvSpPr>
-          <p:cNvPr id="3" name="Card 1"/>
+          <p:cNvPr id="4" name="Card 1"/>
           <p:cNvSpPr/>
           <p:nvPr/>
         </p:nvSpPr>
@@ -5739,7 +5759,7 @@
       </p:sp>
       <p:sp>
         <p:nvSpPr>
-          <p:cNvPr id="4" name="Badge 1"/>
+          <p:cNvPr id="5" name="Badge 1"/>
           <p:cNvSpPr/>
           <p:nvPr/>
         </p:nvSpPr>
@@ -5759,7 +5779,7 @@
       </p:sp>
       <p:sp>
         <p:nvSpPr>
-          <p:cNvPr id="5" name="Numero 1"/>
+          <p:cNvPr id="6" name="Numero 1"/>
           <p:cNvSpPr txBox="1"/>
           <p:nvPr/>
         </p:nvSpPr>
@@ -5795,7 +5815,7 @@
       </p:sp>
       <p:sp>
         <p:nvSpPr>
-          <p:cNvPr id="6" name="Testo 1"/>
+          <p:cNvPr id="7" name="Testo 1"/>
           <p:cNvSpPr txBox="1"/>
           <p:nvPr/>
         </p:nvSpPr>
@@ -5818,34 +5838,34 @@
               <a:buNone/>
             </a:pPr>
             <a:r>
-              <a:rPr lang="en-US" sz="1400" b="1" dirty="0">
+              <a:rPr lang="en-US" sz="1500" b="1" dirty="0">
                 <a:solidFill>
                   <a:schemeClr val="tx1"/>
                 </a:solidFill>
               </a:rPr>
               <a:t>Content-Based (KNN)</a:t>
             </a:r>
-            <a:endParaRPr lang="en-US" sz="1400" dirty="0"/>
+            <a:endParaRPr lang="en-US" sz="1500" dirty="0"/>
           </a:p>
           <a:p>
             <a:pPr indent="0" marL="0">
               <a:buNone/>
             </a:pPr>
             <a:r>
-              <a:rPr lang="en-US" sz="1200" dirty="0">
+              <a:rPr lang="en-US" sz="1300" dirty="0">
                 <a:solidFill>
                   <a:schemeClr val="tx2"/>
                 </a:solidFill>
               </a:rPr>
               <a:t>Immune al cold-start: usa attributi (parcheggio, cucina, atmosfera), latenza minima.</a:t>
             </a:r>
-            <a:endParaRPr lang="en-US" sz="1400" dirty="0"/>
-          </a:p>
-        </p:txBody>
-      </p:sp>
-      <p:sp>
-        <p:nvSpPr>
-          <p:cNvPr id="7" name="Card 2"/>
+            <a:endParaRPr lang="en-US" sz="1500" dirty="0"/>
+          </a:p>
+        </p:txBody>
+      </p:sp>
+      <p:sp>
+        <p:nvSpPr>
+          <p:cNvPr id="8" name="Card 2"/>
           <p:cNvSpPr/>
           <p:nvPr/>
         </p:nvSpPr>
@@ -5867,7 +5887,7 @@
       </p:sp>
       <p:sp>
         <p:nvSpPr>
-          <p:cNvPr id="8" name="Badge 2"/>
+          <p:cNvPr id="9" name="Badge 2"/>
           <p:cNvSpPr/>
           <p:nvPr/>
         </p:nvSpPr>
@@ -5887,7 +5907,7 @@
       </p:sp>
       <p:sp>
         <p:nvSpPr>
-          <p:cNvPr id="9" name="Numero 2"/>
+          <p:cNvPr id="10" name="Numero 2"/>
           <p:cNvSpPr txBox="1"/>
           <p:nvPr/>
         </p:nvSpPr>
@@ -5923,7 +5943,7 @@
       </p:sp>
       <p:sp>
         <p:nvSpPr>
-          <p:cNvPr id="10" name="Testo 2"/>
+          <p:cNvPr id="11" name="Testo 2"/>
           <p:cNvSpPr txBox="1"/>
           <p:nvPr/>
         </p:nvSpPr>
@@ -5946,34 +5966,34 @@
               <a:buNone/>
             </a:pPr>
             <a:r>
-              <a:rPr lang="en-US" sz="1400" b="1" dirty="0">
+              <a:rPr lang="en-US" sz="1500" b="1" dirty="0">
                 <a:solidFill>
                   <a:schemeClr val="tx1"/>
                 </a:solidFill>
               </a:rPr>
               <a:t>Collaborative Filtering (SVD)</a:t>
             </a:r>
-            <a:endParaRPr lang="en-US" sz="1400" dirty="0"/>
+            <a:endParaRPr lang="en-US" sz="1500" dirty="0"/>
           </a:p>
           <a:p>
             <a:pPr indent="0" marL="0">
               <a:buNone/>
             </a:pPr>
             <a:r>
-              <a:rPr lang="en-US" sz="1200" dirty="0">
+              <a:rPr lang="en-US" sz="1300" dirty="0">
                 <a:solidFill>
                   <a:schemeClr val="tx2"/>
                 </a:solidFill>
               </a:rPr>
               <a:t>Estrae relazioni latenti.</a:t>
             </a:r>
-            <a:endParaRPr lang="en-US" sz="1400" dirty="0"/>
-          </a:p>
-        </p:txBody>
-      </p:sp>
-      <p:sp>
-        <p:nvSpPr>
-          <p:cNvPr id="11" name="Card 3"/>
+            <a:endParaRPr lang="en-US" sz="1500" dirty="0"/>
+          </a:p>
+        </p:txBody>
+      </p:sp>
+      <p:sp>
+        <p:nvSpPr>
+          <p:cNvPr id="12" name="Card 3"/>
           <p:cNvSpPr/>
           <p:nvPr/>
         </p:nvSpPr>
@@ -5995,7 +6015,7 @@
       </p:sp>
       <p:sp>
         <p:nvSpPr>
-          <p:cNvPr id="12" name="Badge 3"/>
+          <p:cNvPr id="13" name="Badge 3"/>
           <p:cNvSpPr/>
           <p:nvPr/>
         </p:nvSpPr>
@@ -6015,7 +6035,7 @@
       </p:sp>
       <p:sp>
         <p:nvSpPr>
-          <p:cNvPr id="13" name="Numero 3"/>
+          <p:cNvPr id="14" name="Numero 3"/>
           <p:cNvSpPr txBox="1"/>
           <p:nvPr/>
         </p:nvSpPr>
@@ -6051,7 +6071,7 @@
       </p:sp>
       <p:sp>
         <p:nvSpPr>
-          <p:cNvPr id="14" name="Testo 3"/>
+          <p:cNvPr id="15" name="Testo 3"/>
           <p:cNvSpPr txBox="1"/>
           <p:nvPr/>
         </p:nvSpPr>
@@ -6074,34 +6094,34 @@
               <a:buNone/>
             </a:pPr>
             <a:r>
-              <a:rPr lang="en-US" sz="1400" b="1" dirty="0">
+              <a:rPr lang="en-US" sz="1500" b="1" dirty="0">
                 <a:solidFill>
                   <a:schemeClr val="tx1"/>
                 </a:solidFill>
               </a:rPr>
               <a:t>Deep Learning (Keras Embeddings)</a:t>
             </a:r>
-            <a:endParaRPr lang="en-US" sz="1400" dirty="0"/>
+            <a:endParaRPr lang="en-US" sz="1500" dirty="0"/>
           </a:p>
           <a:p>
             <a:pPr indent="0" marL="0">
               <a:buNone/>
             </a:pPr>
             <a:r>
-              <a:rPr lang="en-US" sz="1200" dirty="0">
+              <a:rPr lang="en-US" sz="1300" dirty="0">
                 <a:solidFill>
                   <a:schemeClr val="tx2"/>
                 </a:solidFill>
               </a:rPr>
               <a:t>Massima accuratezza per suggerimenti super-personalizzati.</a:t>
             </a:r>
-            <a:endParaRPr lang="en-US" sz="1400" dirty="0"/>
+            <a:endParaRPr lang="en-US" sz="1500" dirty="0"/>
           </a:p>
         </p:txBody>
       </p:sp>
       <p:pic>
         <p:nvPicPr>
-          <p:cNvPr id="15" name="Dashboard raccomandazione" descr="Dashboard raccomandazione">    </p:cNvPr>
+          <p:cNvPr id="16" name="Dashboard raccomandazione" descr="Dashboard raccomandazione">    </p:cNvPr>
           <p:cNvPicPr>
             <a:picLocks noChangeAspect="1"/>
           </p:cNvPicPr>
@@ -6132,7 +6152,7 @@
       </p:pic>
       <p:sp>
         <p:nvSpPr>
-          <p:cNvPr id="16" name="Didascalia"/>
+          <p:cNvPr id="17" name="Didascalia"/>
           <p:cNvSpPr txBox="1"/>
           <p:nvPr/>
         </p:nvSpPr>
@@ -6238,7 +6258,7 @@
       </p:grpSpPr>
       <p:sp>
         <p:nvSpPr>
-          <p:cNvPr id="2" name="Text 0"/>
+          <p:cNvPr id="3" name="Text 0"/>
           <p:cNvSpPr/>
           <p:nvPr>
             <p:ph idx="100" type="title" hasCustomPrompt="1"/>
@@ -6276,7 +6296,7 @@
       </p:sp>
       <p:sp>
         <p:nvSpPr>
-          <p:cNvPr id="3" name="Card stat 1"/>
+          <p:cNvPr id="4" name="Card stat 1"/>
           <p:cNvSpPr/>
           <p:nvPr/>
         </p:nvSpPr>
@@ -6305,7 +6325,7 @@
       </p:sp>
       <p:sp>
         <p:nvSpPr>
-          <p:cNvPr id="4" name="Stat 1"/>
+          <p:cNvPr id="5" name="Stat 1"/>
           <p:cNvSpPr txBox="1"/>
           <p:nvPr/>
         </p:nvSpPr>
@@ -6345,12 +6365,12 @@
               <a:buNone/>
             </a:pPr>
             <a:r>
-              <a:rPr lang="en-US" sz="1100" dirty="0">
+              <a:rPr lang="en-US" sz="1200" dirty="0">
                 <a:solidFill>
                   <a:schemeClr val="bg1"/>
                 </a:solidFill>
               </a:rPr>
-              <a:t>compressione dati: 5 GB → 50-80 MB</a:t>
+              <a:t>compressione dati in formato ottimizzato</a:t>
             </a:r>
             <a:endParaRPr lang="en-US" sz="2600" dirty="0"/>
           </a:p>
@@ -6358,7 +6378,7 @@
       </p:sp>
       <p:sp>
         <p:nvSpPr>
-          <p:cNvPr id="5" name="Card stat 2"/>
+          <p:cNvPr id="6" name="Card stat 2"/>
           <p:cNvSpPr/>
           <p:nvPr/>
         </p:nvSpPr>
@@ -6387,7 +6407,7 @@
       </p:sp>
       <p:sp>
         <p:nvSpPr>
-          <p:cNvPr id="6" name="Stat 2"/>
+          <p:cNvPr id="7" name="Stat 2"/>
           <p:cNvSpPr txBox="1"/>
           <p:nvPr/>
         </p:nvSpPr>
@@ -6427,7 +6447,7 @@
               <a:buNone/>
             </a:pPr>
             <a:r>
-              <a:rPr lang="en-US" sz="1100" dirty="0">
+              <a:rPr lang="en-US" sz="1200" dirty="0">
                 <a:solidFill>
                   <a:schemeClr val="bg1"/>
                 </a:solidFill>
@@ -6440,7 +6460,7 @@
       </p:sp>
       <p:sp>
         <p:nvSpPr>
-          <p:cNvPr id="7" name="Card stat 3"/>
+          <p:cNvPr id="8" name="Card stat 3"/>
           <p:cNvSpPr/>
           <p:nvPr/>
         </p:nvSpPr>
@@ -6469,7 +6489,7 @@
       </p:sp>
       <p:sp>
         <p:nvSpPr>
-          <p:cNvPr id="8" name="Stat 3"/>
+          <p:cNvPr id="9" name="Stat 3"/>
           <p:cNvSpPr txBox="1"/>
           <p:nvPr/>
         </p:nvSpPr>
@@ -6509,7 +6529,7 @@
               <a:buNone/>
             </a:pPr>
             <a:r>
-              <a:rPr lang="en-US" sz="1100" dirty="0">
+              <a:rPr lang="en-US" sz="1200" dirty="0">
                 <a:solidFill>
                   <a:schemeClr val="bg1"/>
                 </a:solidFill>
@@ -6522,7 +6542,7 @@
       </p:sp>
       <p:sp>
         <p:nvSpPr>
-          <p:cNvPr id="9" name="Card stat 4"/>
+          <p:cNvPr id="10" name="Card stat 4"/>
           <p:cNvSpPr/>
           <p:nvPr/>
         </p:nvSpPr>
@@ -6551,7 +6571,7 @@
       </p:sp>
       <p:sp>
         <p:nvSpPr>
-          <p:cNvPr id="10" name="Stat 4"/>
+          <p:cNvPr id="11" name="Stat 4"/>
           <p:cNvSpPr txBox="1"/>
           <p:nvPr/>
         </p:nvSpPr>
@@ -6591,7 +6611,7 @@
               <a:buNone/>
             </a:pPr>
             <a:r>
-              <a:rPr lang="en-US" sz="1100" dirty="0">
+              <a:rPr lang="en-US" sz="1200" dirty="0">
                 <a:solidFill>
                   <a:schemeClr val="bg1"/>
                 </a:solidFill>
@@ -6604,7 +6624,7 @@
       </p:sp>
       <p:graphicFrame>
         <p:nvGraphicFramePr>
-          <p:cNvPr id="11" name="Chart 0" descr=""/>
+          <p:cNvPr id="12" name="Chart 0" descr=""/>
           <p:cNvGraphicFramePr/>
           <p:nvPr/>
         </p:nvGraphicFramePr>
@@ -6620,7 +6640,7 @@
       </p:graphicFrame>
       <p:sp>
         <p:nvSpPr>
-          <p:cNvPr id="12" name="Box spiegazione"/>
+          <p:cNvPr id="13" name="Box spiegazione"/>
           <p:cNvSpPr/>
           <p:nvPr/>
         </p:nvSpPr>
@@ -6642,7 +6662,7 @@
       </p:sp>
       <p:sp>
         <p:nvSpPr>
-          <p:cNvPr id="13" name="Spiegazione"/>
+          <p:cNvPr id="14" name="Spiegazione"/>
           <p:cNvSpPr txBox="1"/>
           <p:nvPr/>
         </p:nvSpPr>
@@ -6682,7 +6702,7 @@
               <a:buNone/>
             </a:pPr>
             <a:r>
-              <a:rPr lang="en-US" sz="1200" dirty="0">
+              <a:rPr lang="en-US" sz="1300" dirty="0">
                 <a:solidFill>
                   <a:schemeClr val="tx1"/>
                 </a:solidFill>
@@ -6696,7 +6716,7 @@
               <a:buNone/>
             </a:pPr>
             <a:r>
-              <a:rPr lang="en-US" sz="1200" dirty="0">
+              <a:rPr lang="en-US" sz="1300" dirty="0">
                 <a:solidFill>
                   <a:schemeClr val="tx1"/>
                 </a:solidFill>
@@ -6779,7 +6799,7 @@
       </p:grpSpPr>
       <p:sp>
         <p:nvSpPr>
-          <p:cNvPr id="2" name="Text 0"/>
+          <p:cNvPr id="3" name="Text 0"/>
           <p:cNvSpPr/>
           <p:nvPr>
             <p:ph idx="100" type="title" hasCustomPrompt="1"/>
@@ -6817,7 +6837,7 @@
       </p:sp>
       <p:pic>
         <p:nvPicPr>
-          <p:cNvPr id="3" name="Dashboard benchmark pipeline" descr="Dashboard benchmark pipeline">    </p:cNvPr>
+          <p:cNvPr id="4" name="Dashboard benchmark pipeline" descr="Dashboard benchmark pipeline">    </p:cNvPr>
           <p:cNvPicPr>
             <a:picLocks noChangeAspect="1"/>
           </p:cNvPicPr>
@@ -6848,7 +6868,7 @@
       </p:pic>
       <p:sp>
         <p:nvSpPr>
-          <p:cNvPr id="4" name="Didascalia"/>
+          <p:cNvPr id="5" name="Didascalia"/>
           <p:cNvSpPr txBox="1"/>
           <p:nvPr/>
         </p:nvSpPr>
@@ -6884,7 +6904,7 @@
       </p:sp>
       <p:sp>
         <p:nvSpPr>
-          <p:cNvPr id="5" name="Valore"/>
+          <p:cNvPr id="6" name="Valore"/>
           <p:cNvSpPr txBox="1"/>
           <p:nvPr/>
         </p:nvSpPr>
@@ -6934,7 +6954,7 @@
       </p:sp>
       <p:sp>
         <p:nvSpPr>
-          <p:cNvPr id="6" name="Trade-off"/>
+          <p:cNvPr id="7" name="Trade-off"/>
           <p:cNvSpPr txBox="1"/>
           <p:nvPr/>
         </p:nvSpPr>
@@ -6984,7 +7004,7 @@
       </p:sp>
       <p:sp>
         <p:nvSpPr>
-          <p:cNvPr id="7" name="Dashboard"/>
+          <p:cNvPr id="8" name="Dashboard"/>
           <p:cNvSpPr txBox="1"/>
           <p:nvPr/>
         </p:nvSpPr>

</xml_diff>